<commit_message>
fix: update Presentation-HU.pptx with latest changes
</commit_message>
<xml_diff>
--- a/documents/Presentation-HU.pptx
+++ b/documents/Presentation-HU.pptx
@@ -104,6 +104,11 @@
       </a:defRPr>
     </a:lvl9pPr>
   </p:defaultTextStyle>
+  <p:extLst>
+    <p:ext uri="{EFAFB233-063F-42B5-8137-9DF3F51BA10A}">
+      <p15:sldGuideLst xmlns:p15="http://schemas.microsoft.com/office/powerpoint/2012/main"/>
+    </p:ext>
+  </p:extLst>
 </p:presentation>
 </file>
 
@@ -126,6 +131,125 @@
       </p:grpSpPr>
       <p:sp>
         <p:nvSpPr>
+          <p:cNvPr id="4" name="Dátum helye 3">
+            <a:extLst>
+              <a:ext uri="{FF2B5EF4-FFF2-40B4-BE49-F238E27FC236}">
+                <a16:creationId xmlns:a16="http://schemas.microsoft.com/office/drawing/2014/main" id="{B8BBE37E-CDF7-4B4A-8068-117B5D04B626}"/>
+              </a:ext>
+            </a:extLst>
+          </p:cNvPr>
+          <p:cNvSpPr>
+            <a:spLocks noGrp="1"/>
+          </p:cNvSpPr>
+          <p:nvPr>
+            <p:ph type="dt" sz="half" idx="10"/>
+          </p:nvPr>
+        </p:nvSpPr>
+        <p:spPr/>
+        <p:txBody>
+          <a:bodyPr/>
+          <a:lstStyle/>
+          <a:p>
+            <a:fld id="{9C43E641-41DE-4131-BE43-BEBEB6171E7E}" type="datetimeFigureOut">
+              <a:rPr lang="hu-HU" smtClean="0"/>
+              <a:t>2026. 05. 06.</a:t>
+            </a:fld>
+            <a:endParaRPr lang="hu-HU"/>
+          </a:p>
+        </p:txBody>
+      </p:sp>
+      <p:sp>
+        <p:nvSpPr>
+          <p:cNvPr id="5" name="Élőláb helye 4">
+            <a:extLst>
+              <a:ext uri="{FF2B5EF4-FFF2-40B4-BE49-F238E27FC236}">
+                <a16:creationId xmlns:a16="http://schemas.microsoft.com/office/drawing/2014/main" id="{79C278B0-B10A-482F-ACAE-2ACB84280CAB}"/>
+              </a:ext>
+            </a:extLst>
+          </p:cNvPr>
+          <p:cNvSpPr>
+            <a:spLocks noGrp="1"/>
+          </p:cNvSpPr>
+          <p:nvPr>
+            <p:ph type="ftr" sz="quarter" idx="11"/>
+          </p:nvPr>
+        </p:nvSpPr>
+        <p:spPr/>
+        <p:txBody>
+          <a:bodyPr/>
+          <a:lstStyle/>
+          <a:p>
+            <a:endParaRPr lang="hu-HU"/>
+          </a:p>
+        </p:txBody>
+      </p:sp>
+      <p:sp>
+        <p:nvSpPr>
+          <p:cNvPr id="6" name="Dia számának helye 5">
+            <a:extLst>
+              <a:ext uri="{FF2B5EF4-FFF2-40B4-BE49-F238E27FC236}">
+                <a16:creationId xmlns:a16="http://schemas.microsoft.com/office/drawing/2014/main" id="{098D804C-A2E7-481F-BE58-7AF530D773ED}"/>
+              </a:ext>
+            </a:extLst>
+          </p:cNvPr>
+          <p:cNvSpPr>
+            <a:spLocks noGrp="1"/>
+          </p:cNvSpPr>
+          <p:nvPr>
+            <p:ph type="sldNum" sz="quarter" idx="12"/>
+          </p:nvPr>
+        </p:nvSpPr>
+        <p:spPr/>
+        <p:txBody>
+          <a:bodyPr/>
+          <a:lstStyle/>
+          <a:p>
+            <a:fld id="{94F0C352-B0A6-4D12-8939-629BB6292242}" type="slidenum">
+              <a:rPr lang="hu-HU" smtClean="0"/>
+              <a:t>‹#›</a:t>
+            </a:fld>
+            <a:endParaRPr lang="hu-HU"/>
+          </a:p>
+        </p:txBody>
+      </p:sp>
+      <p:pic>
+        <p:nvPicPr>
+          <p:cNvPr id="10" name="Kép 9" descr="A képen sport, Fizikai erőnlét, súlyzó látható&#10;&#10;Előfordulhat, hogy a mesterséges intelligencia által létrehozott tartalom helytelen.">
+            <a:extLst>
+              <a:ext uri="{FF2B5EF4-FFF2-40B4-BE49-F238E27FC236}">
+                <a16:creationId xmlns:a16="http://schemas.microsoft.com/office/drawing/2014/main" id="{4FD29315-FEB0-D33C-F364-3A0A5AB6C958}"/>
+              </a:ext>
+            </a:extLst>
+          </p:cNvPr>
+          <p:cNvPicPr>
+            <a:picLocks noChangeAspect="1"/>
+          </p:cNvPicPr>
+          <p:nvPr userDrawn="1"/>
+        </p:nvPicPr>
+        <p:blipFill>
+          <a:blip r:embed="rId2">
+            <a:extLst>
+              <a:ext uri="{28A0092B-C50C-407E-A947-70E740481C1C}">
+                <a14:useLocalDpi xmlns:a14="http://schemas.microsoft.com/office/drawing/2010/main" val="0"/>
+              </a:ext>
+            </a:extLst>
+          </a:blip>
+          <a:stretch>
+            <a:fillRect/>
+          </a:stretch>
+        </p:blipFill>
+        <p:spPr>
+          <a:xfrm>
+            <a:off x="4204854" y="1537854"/>
+            <a:ext cx="3782291" cy="3782291"/>
+          </a:xfrm>
+          <a:prstGeom prst="rect">
+            <a:avLst/>
+          </a:prstGeom>
+        </p:spPr>
+      </p:pic>
+      <p:sp>
+        <p:nvSpPr>
           <p:cNvPr id="2" name="Cím 1">
             <a:extLst>
               <a:ext uri="{FF2B5EF4-FFF2-40B4-BE49-F238E27FC236}">
@@ -147,15 +271,15 @@
           </a:xfrm>
         </p:spPr>
         <p:txBody>
-          <a:bodyPr anchor="b"/>
+          <a:bodyPr anchor="t"/>
           <a:lstStyle>
             <a:lvl1pPr algn="ctr">
-              <a:defRPr sz="6000"/>
+              <a:defRPr sz="6000" b="1"/>
             </a:lvl1pPr>
           </a:lstStyle>
           <a:p>
             <a:r>
-              <a:rPr lang="hu-HU"/>
+              <a:rPr lang="hu-HU" dirty="0"/>
               <a:t>Mintacím szerkesztése</a:t>
             </a:r>
           </a:p>
@@ -184,7 +308,7 @@
           </a:xfrm>
         </p:spPr>
         <p:txBody>
-          <a:bodyPr/>
+          <a:bodyPr anchor="b"/>
           <a:lstStyle>
             <a:lvl1pPr marL="0" indent="0" algn="ctr">
               <a:buNone/>
@@ -225,92 +349,9 @@
           </a:lstStyle>
           <a:p>
             <a:r>
-              <a:rPr lang="hu-HU"/>
+              <a:rPr lang="hu-HU" dirty="0"/>
               <a:t>Kattintson ide az alcím mintájának szerkesztéséhez</a:t>
             </a:r>
-          </a:p>
-        </p:txBody>
-      </p:sp>
-      <p:sp>
-        <p:nvSpPr>
-          <p:cNvPr id="4" name="Dátum helye 3">
-            <a:extLst>
-              <a:ext uri="{FF2B5EF4-FFF2-40B4-BE49-F238E27FC236}">
-                <a16:creationId xmlns:a16="http://schemas.microsoft.com/office/drawing/2014/main" id="{B8BBE37E-CDF7-4B4A-8068-117B5D04B626}"/>
-              </a:ext>
-            </a:extLst>
-          </p:cNvPr>
-          <p:cNvSpPr>
-            <a:spLocks noGrp="1"/>
-          </p:cNvSpPr>
-          <p:nvPr>
-            <p:ph type="dt" sz="half" idx="10"/>
-          </p:nvPr>
-        </p:nvSpPr>
-        <p:spPr/>
-        <p:txBody>
-          <a:bodyPr/>
-          <a:lstStyle/>
-          <a:p>
-            <a:fld id="{9C43E641-41DE-4131-BE43-BEBEB6171E7E}" type="datetimeFigureOut">
-              <a:rPr lang="hu-HU" smtClean="0"/>
-              <a:t>2025. 10. 13.</a:t>
-            </a:fld>
-            <a:endParaRPr lang="hu-HU"/>
-          </a:p>
-        </p:txBody>
-      </p:sp>
-      <p:sp>
-        <p:nvSpPr>
-          <p:cNvPr id="5" name="Élőláb helye 4">
-            <a:extLst>
-              <a:ext uri="{FF2B5EF4-FFF2-40B4-BE49-F238E27FC236}">
-                <a16:creationId xmlns:a16="http://schemas.microsoft.com/office/drawing/2014/main" id="{79C278B0-B10A-482F-ACAE-2ACB84280CAB}"/>
-              </a:ext>
-            </a:extLst>
-          </p:cNvPr>
-          <p:cNvSpPr>
-            <a:spLocks noGrp="1"/>
-          </p:cNvSpPr>
-          <p:nvPr>
-            <p:ph type="ftr" sz="quarter" idx="11"/>
-          </p:nvPr>
-        </p:nvSpPr>
-        <p:spPr/>
-        <p:txBody>
-          <a:bodyPr/>
-          <a:lstStyle/>
-          <a:p>
-            <a:endParaRPr lang="hu-HU"/>
-          </a:p>
-        </p:txBody>
-      </p:sp>
-      <p:sp>
-        <p:nvSpPr>
-          <p:cNvPr id="6" name="Dia számának helye 5">
-            <a:extLst>
-              <a:ext uri="{FF2B5EF4-FFF2-40B4-BE49-F238E27FC236}">
-                <a16:creationId xmlns:a16="http://schemas.microsoft.com/office/drawing/2014/main" id="{098D804C-A2E7-481F-BE58-7AF530D773ED}"/>
-              </a:ext>
-            </a:extLst>
-          </p:cNvPr>
-          <p:cNvSpPr>
-            <a:spLocks noGrp="1"/>
-          </p:cNvSpPr>
-          <p:nvPr>
-            <p:ph type="sldNum" sz="quarter" idx="12"/>
-          </p:nvPr>
-        </p:nvSpPr>
-        <p:spPr/>
-        <p:txBody>
-          <a:bodyPr/>
-          <a:lstStyle/>
-          <a:p>
-            <a:fld id="{94F0C352-B0A6-4D12-8939-629BB6292242}" type="slidenum">
-              <a:rPr lang="hu-HU" smtClean="0"/>
-              <a:t>‹#›</a:t>
-            </a:fld>
-            <a:endParaRPr lang="hu-HU"/>
           </a:p>
         </p:txBody>
       </p:sp>
@@ -452,7 +493,7 @@
           <a:p>
             <a:fld id="{9C43E641-41DE-4131-BE43-BEBEB6171E7E}" type="datetimeFigureOut">
               <a:rPr lang="hu-HU" smtClean="0"/>
-              <a:t>2025. 10. 13.</a:t>
+              <a:t>2026. 05. 06.</a:t>
             </a:fld>
             <a:endParaRPr lang="hu-HU"/>
           </a:p>
@@ -660,7 +701,7 @@
           <a:p>
             <a:fld id="{9C43E641-41DE-4131-BE43-BEBEB6171E7E}" type="datetimeFigureOut">
               <a:rPr lang="hu-HU" smtClean="0"/>
-              <a:t>2025. 10. 13.</a:t>
+              <a:t>2026. 05. 06.</a:t>
             </a:fld>
             <a:endParaRPr lang="hu-HU"/>
           </a:p>
@@ -766,13 +807,27 @@
             <p:ph type="title"/>
           </p:nvPr>
         </p:nvSpPr>
-        <p:spPr/>
-        <p:txBody>
-          <a:bodyPr/>
-          <a:lstStyle/>
-          <a:p>
-            <a:r>
-              <a:rPr lang="hu-HU"/>
+        <p:spPr>
+          <a:xfrm>
+            <a:off x="838200" y="365125"/>
+            <a:ext cx="10515600" cy="1325563"/>
+          </a:xfrm>
+        </p:spPr>
+        <p:txBody>
+          <a:bodyPr/>
+          <a:lstStyle>
+            <a:lvl1pPr>
+              <a:defRPr>
+                <a:solidFill>
+                  <a:schemeClr val="tx1"/>
+                </a:solidFill>
+                <a:latin typeface="Arial Black" panose="020B0A04020102020204" pitchFamily="34" charset="0"/>
+              </a:defRPr>
+            </a:lvl1pPr>
+          </a:lstStyle>
+          <a:p>
+            <a:r>
+              <a:rPr lang="hu-HU" dirty="0"/>
               <a:t>Mintacím szerkesztése</a:t>
             </a:r>
           </a:p>
@@ -801,35 +856,35 @@
           <a:p>
             <a:pPr lvl="0"/>
             <a:r>
-              <a:rPr lang="hu-HU"/>
+              <a:rPr lang="hu-HU" dirty="0"/>
               <a:t>Mintaszöveg szerkesztése</a:t>
             </a:r>
           </a:p>
           <a:p>
             <a:pPr lvl="1"/>
             <a:r>
-              <a:rPr lang="hu-HU"/>
+              <a:rPr lang="hu-HU" dirty="0"/>
               <a:t>Második szint</a:t>
             </a:r>
           </a:p>
           <a:p>
             <a:pPr lvl="2"/>
             <a:r>
-              <a:rPr lang="hu-HU"/>
+              <a:rPr lang="hu-HU" dirty="0"/>
               <a:t>Harmadik szint</a:t>
             </a:r>
           </a:p>
           <a:p>
             <a:pPr lvl="3"/>
             <a:r>
-              <a:rPr lang="hu-HU"/>
+              <a:rPr lang="hu-HU" dirty="0"/>
               <a:t>Negyedik szint</a:t>
             </a:r>
           </a:p>
           <a:p>
             <a:pPr lvl="4"/>
             <a:r>
-              <a:rPr lang="hu-HU"/>
+              <a:rPr lang="hu-HU" dirty="0"/>
               <a:t>Ötödik szint</a:t>
             </a:r>
           </a:p>
@@ -858,7 +913,7 @@
           <a:p>
             <a:fld id="{9C43E641-41DE-4131-BE43-BEBEB6171E7E}" type="datetimeFigureOut">
               <a:rPr lang="hu-HU" smtClean="0"/>
-              <a:t>2025. 10. 13.</a:t>
+              <a:t>2026. 05. 06.</a:t>
             </a:fld>
             <a:endParaRPr lang="hu-HU"/>
           </a:p>
@@ -1133,7 +1188,7 @@
           <a:p>
             <a:fld id="{9C43E641-41DE-4131-BE43-BEBEB6171E7E}" type="datetimeFigureOut">
               <a:rPr lang="hu-HU" smtClean="0"/>
-              <a:t>2025. 10. 13.</a:t>
+              <a:t>2026. 05. 06.</a:t>
             </a:fld>
             <a:endParaRPr lang="hu-HU"/>
           </a:p>
@@ -1398,7 +1453,7 @@
           <a:p>
             <a:fld id="{9C43E641-41DE-4131-BE43-BEBEB6171E7E}" type="datetimeFigureOut">
               <a:rPr lang="hu-HU" smtClean="0"/>
-              <a:t>2025. 10. 13.</a:t>
+              <a:t>2026. 05. 06.</a:t>
             </a:fld>
             <a:endParaRPr lang="hu-HU"/>
           </a:p>
@@ -1810,7 +1865,7 @@
           <a:p>
             <a:fld id="{9C43E641-41DE-4131-BE43-BEBEB6171E7E}" type="datetimeFigureOut">
               <a:rPr lang="hu-HU" smtClean="0"/>
-              <a:t>2025. 10. 13.</a:t>
+              <a:t>2026. 05. 06.</a:t>
             </a:fld>
             <a:endParaRPr lang="hu-HU"/>
           </a:p>
@@ -1951,7 +2006,7 @@
           <a:p>
             <a:fld id="{9C43E641-41DE-4131-BE43-BEBEB6171E7E}" type="datetimeFigureOut">
               <a:rPr lang="hu-HU" smtClean="0"/>
-              <a:t>2025. 10. 13.</a:t>
+              <a:t>2026. 05. 06.</a:t>
             </a:fld>
             <a:endParaRPr lang="hu-HU"/>
           </a:p>
@@ -2064,7 +2119,7 @@
           <a:p>
             <a:fld id="{9C43E641-41DE-4131-BE43-BEBEB6171E7E}" type="datetimeFigureOut">
               <a:rPr lang="hu-HU" smtClean="0"/>
-              <a:t>2025. 10. 13.</a:t>
+              <a:t>2026. 05. 06.</a:t>
             </a:fld>
             <a:endParaRPr lang="hu-HU"/>
           </a:p>
@@ -2375,7 +2430,7 @@
           <a:p>
             <a:fld id="{9C43E641-41DE-4131-BE43-BEBEB6171E7E}" type="datetimeFigureOut">
               <a:rPr lang="hu-HU" smtClean="0"/>
-              <a:t>2025. 10. 13.</a:t>
+              <a:t>2026. 05. 06.</a:t>
             </a:fld>
             <a:endParaRPr lang="hu-HU"/>
           </a:p>
@@ -2663,7 +2718,7 @@
           <a:p>
             <a:fld id="{9C43E641-41DE-4131-BE43-BEBEB6171E7E}" type="datetimeFigureOut">
               <a:rPr lang="hu-HU" smtClean="0"/>
-              <a:t>2025. 10. 13.</a:t>
+              <a:t>2026. 05. 06.</a:t>
             </a:fld>
             <a:endParaRPr lang="hu-HU"/>
           </a:p>
@@ -2904,7 +2959,7 @@
           <a:p>
             <a:fld id="{9C43E641-41DE-4131-BE43-BEBEB6171E7E}" type="datetimeFigureOut">
               <a:rPr lang="hu-HU" smtClean="0"/>
-              <a:t>2025. 10. 13.</a:t>
+              <a:t>2026. 05. 06.</a:t>
             </a:fld>
             <a:endParaRPr lang="hu-HU"/>
           </a:p>
@@ -3007,7 +3062,7 @@
       </p:ext>
     </p:extLst>
   </p:cSld>
-  <p:clrMap bg1="lt1" tx1="dk1" bg2="lt2" tx2="dk2" accent1="accent1" accent2="accent2" accent3="accent3" accent4="accent4" accent5="accent5" accent6="accent6" hlink="hlink" folHlink="folHlink"/>
+  <p:clrMap bg1="dk1" tx1="lt1" bg2="dk2" tx2="lt2" accent1="accent1" accent2="accent2" accent3="accent3" accent4="accent4" accent5="accent5" accent6="accent6" hlink="hlink" folHlink="folHlink"/>
   <p:sldLayoutIdLst>
     <p:sldLayoutId id="2147483649" r:id="rId1"/>
     <p:sldLayoutId id="2147483650" r:id="rId2"/>
@@ -3342,7 +3397,15 @@
           <a:bodyPr/>
           <a:lstStyle/>
           <a:p>
-            <a:endParaRPr lang="hu-HU"/>
+            <a:r>
+              <a:rPr lang="hu-HU" b="1" dirty="0">
+                <a:solidFill>
+                  <a:srgbClr val="FF0000"/>
+                </a:solidFill>
+                <a:latin typeface="Arial Black" panose="020B0A04020102020204" pitchFamily="34" charset="0"/>
+              </a:rPr>
+              <a:t>MaxxedOut</a:t>
+            </a:r>
           </a:p>
         </p:txBody>
       </p:sp>
@@ -3362,12 +3425,44 @@
             <p:ph type="subTitle" idx="1"/>
           </p:nvPr>
         </p:nvSpPr>
-        <p:spPr/>
-        <p:txBody>
-          <a:bodyPr/>
-          <a:lstStyle/>
-          <a:p>
-            <a:endParaRPr lang="hu-HU"/>
+        <p:spPr>
+          <a:xfrm>
+            <a:off x="1524000" y="4079875"/>
+            <a:ext cx="9144000" cy="1655762"/>
+          </a:xfrm>
+        </p:spPr>
+        <p:txBody>
+          <a:bodyPr>
+            <a:normAutofit/>
+          </a:bodyPr>
+          <a:lstStyle/>
+          <a:p>
+            <a:r>
+              <a:rPr lang="hu-HU" sz="2000" dirty="0"/>
+              <a:t>Készítők: </a:t>
+            </a:r>
+          </a:p>
+          <a:p>
+            <a:r>
+              <a:rPr lang="hu-HU" sz="2000" dirty="0"/>
+              <a:t>Medovarszki János | </a:t>
+            </a:r>
+            <a:r>
+              <a:rPr lang="hu-HU" sz="2000" dirty="0" err="1"/>
+              <a:t>Tekeres</a:t>
+            </a:r>
+            <a:r>
+              <a:rPr lang="hu-HU" sz="2000" dirty="0"/>
+              <a:t> Dénes | </a:t>
+            </a:r>
+            <a:r>
+              <a:rPr lang="hu-HU" sz="2000" dirty="0" err="1"/>
+              <a:t>Teveli</a:t>
+            </a:r>
+            <a:r>
+              <a:rPr lang="hu-HU" sz="2000" dirty="0"/>
+              <a:t> András</a:t>
+            </a:r>
           </a:p>
         </p:txBody>
       </p:sp>

</xml_diff>